<commit_message>
P&L: tighten row pitch so operating-income row fits under divider inside card
</commit_message>
<xml_diff>
--- a/Playa-Vista-ASC-Investor-Deck.pptx
+++ b/Playa-Vista-ASC-Investor-Deck.pptx
@@ -3534,8 +3534,8 @@
         </p:nvSpPr>
         <p:spPr>
           <a:xfrm>
-            <a:off x="868680" y="2039112"/>
-            <a:ext cx="4114800" cy="278892"/>
+            <a:off x="868680" y="2020824"/>
+            <a:ext cx="4114800" cy="246888"/>
           </a:xfrm>
           <a:prstGeom prst="rect">
             <a:avLst/>
@@ -3573,8 +3573,8 @@
         </p:nvSpPr>
         <p:spPr>
           <a:xfrm>
-            <a:off x="4892040" y="2039112"/>
-            <a:ext cx="1463040" cy="278892"/>
+            <a:off x="4892040" y="2020824"/>
+            <a:ext cx="1463040" cy="246888"/>
           </a:xfrm>
           <a:prstGeom prst="rect">
             <a:avLst/>
@@ -3612,8 +3612,8 @@
         </p:nvSpPr>
         <p:spPr>
           <a:xfrm>
-            <a:off x="6400800" y="2039112"/>
-            <a:ext cx="457200" cy="278892"/>
+            <a:off x="6400800" y="2020824"/>
+            <a:ext cx="457200" cy="246888"/>
           </a:xfrm>
           <a:prstGeom prst="rect">
             <a:avLst/>
@@ -3651,8 +3651,8 @@
         </p:nvSpPr>
         <p:spPr>
           <a:xfrm>
-            <a:off x="868680" y="2359152"/>
-            <a:ext cx="4114800" cy="278892"/>
+            <a:off x="868680" y="2301545"/>
+            <a:ext cx="4114800" cy="246888"/>
           </a:xfrm>
           <a:prstGeom prst="rect">
             <a:avLst/>
@@ -3690,8 +3690,8 @@
         </p:nvSpPr>
         <p:spPr>
           <a:xfrm>
-            <a:off x="4892040" y="2359152"/>
-            <a:ext cx="1463040" cy="278892"/>
+            <a:off x="4892040" y="2301545"/>
+            <a:ext cx="1463040" cy="246888"/>
           </a:xfrm>
           <a:prstGeom prst="rect">
             <a:avLst/>
@@ -3729,8 +3729,8 @@
         </p:nvSpPr>
         <p:spPr>
           <a:xfrm>
-            <a:off x="548640" y="2660904"/>
-            <a:ext cx="6492240" cy="315468"/>
+            <a:off x="548640" y="2563978"/>
+            <a:ext cx="6492240" cy="283464"/>
           </a:xfrm>
           <a:prstGeom prst="rect">
             <a:avLst/>
@@ -3749,8 +3749,8 @@
         </p:nvSpPr>
         <p:spPr>
           <a:xfrm>
-            <a:off x="868680" y="2679192"/>
-            <a:ext cx="4114800" cy="278892"/>
+            <a:off x="868680" y="2582266"/>
+            <a:ext cx="4114800" cy="246888"/>
           </a:xfrm>
           <a:prstGeom prst="rect">
             <a:avLst/>
@@ -3788,8 +3788,8 @@
         </p:nvSpPr>
         <p:spPr>
           <a:xfrm>
-            <a:off x="4892040" y="2679192"/>
-            <a:ext cx="1463040" cy="278892"/>
+            <a:off x="4892040" y="2582266"/>
+            <a:ext cx="1463040" cy="246888"/>
           </a:xfrm>
           <a:prstGeom prst="rect">
             <a:avLst/>
@@ -3827,8 +3827,8 @@
         </p:nvSpPr>
         <p:spPr>
           <a:xfrm>
-            <a:off x="6400800" y="2679192"/>
-            <a:ext cx="457200" cy="278892"/>
+            <a:off x="6400800" y="2582266"/>
+            <a:ext cx="457200" cy="246888"/>
           </a:xfrm>
           <a:prstGeom prst="rect">
             <a:avLst/>
@@ -3866,8 +3866,8 @@
         </p:nvSpPr>
         <p:spPr>
           <a:xfrm>
-            <a:off x="868680" y="2999232"/>
-            <a:ext cx="4114800" cy="278892"/>
+            <a:off x="868680" y="2862986"/>
+            <a:ext cx="4114800" cy="246888"/>
           </a:xfrm>
           <a:prstGeom prst="rect">
             <a:avLst/>
@@ -3905,8 +3905,8 @@
         </p:nvSpPr>
         <p:spPr>
           <a:xfrm>
-            <a:off x="4892040" y="2999232"/>
-            <a:ext cx="1463040" cy="278892"/>
+            <a:off x="4892040" y="2862986"/>
+            <a:ext cx="1463040" cy="246888"/>
           </a:xfrm>
           <a:prstGeom prst="rect">
             <a:avLst/>
@@ -3944,8 +3944,8 @@
         </p:nvSpPr>
         <p:spPr>
           <a:xfrm>
-            <a:off x="868680" y="3319272"/>
-            <a:ext cx="4114800" cy="278892"/>
+            <a:off x="868680" y="3143707"/>
+            <a:ext cx="4114800" cy="246888"/>
           </a:xfrm>
           <a:prstGeom prst="rect">
             <a:avLst/>
@@ -3983,8 +3983,8 @@
         </p:nvSpPr>
         <p:spPr>
           <a:xfrm>
-            <a:off x="4892040" y="3319272"/>
-            <a:ext cx="1463040" cy="278892"/>
+            <a:off x="4892040" y="3143707"/>
+            <a:ext cx="1463040" cy="246888"/>
           </a:xfrm>
           <a:prstGeom prst="rect">
             <a:avLst/>
@@ -4022,8 +4022,8 @@
         </p:nvSpPr>
         <p:spPr>
           <a:xfrm>
-            <a:off x="868680" y="3639312"/>
-            <a:ext cx="4114800" cy="278892"/>
+            <a:off x="868680" y="3424428"/>
+            <a:ext cx="4114800" cy="246888"/>
           </a:xfrm>
           <a:prstGeom prst="rect">
             <a:avLst/>
@@ -4061,8 +4061,8 @@
         </p:nvSpPr>
         <p:spPr>
           <a:xfrm>
-            <a:off x="4892040" y="3639312"/>
-            <a:ext cx="1463040" cy="278892"/>
+            <a:off x="4892040" y="3424428"/>
+            <a:ext cx="1463040" cy="246888"/>
           </a:xfrm>
           <a:prstGeom prst="rect">
             <a:avLst/>
@@ -4100,8 +4100,8 @@
         </p:nvSpPr>
         <p:spPr>
           <a:xfrm>
-            <a:off x="868680" y="3959352"/>
-            <a:ext cx="4114800" cy="278892"/>
+            <a:off x="868680" y="3705149"/>
+            <a:ext cx="4114800" cy="246888"/>
           </a:xfrm>
           <a:prstGeom prst="rect">
             <a:avLst/>
@@ -4139,8 +4139,8 @@
         </p:nvSpPr>
         <p:spPr>
           <a:xfrm>
-            <a:off x="4892040" y="3959352"/>
-            <a:ext cx="1463040" cy="278892"/>
+            <a:off x="4892040" y="3705149"/>
+            <a:ext cx="1463040" cy="246888"/>
           </a:xfrm>
           <a:prstGeom prst="rect">
             <a:avLst/>
@@ -4178,8 +4178,8 @@
         </p:nvSpPr>
         <p:spPr>
           <a:xfrm>
-            <a:off x="868680" y="4279392"/>
-            <a:ext cx="4114800" cy="278892"/>
+            <a:off x="868680" y="3985870"/>
+            <a:ext cx="4114800" cy="246888"/>
           </a:xfrm>
           <a:prstGeom prst="rect">
             <a:avLst/>
@@ -4217,8 +4217,8 @@
         </p:nvSpPr>
         <p:spPr>
           <a:xfrm>
-            <a:off x="4892040" y="4279392"/>
-            <a:ext cx="1463040" cy="278892"/>
+            <a:off x="4892040" y="3985870"/>
+            <a:ext cx="1463040" cy="246888"/>
           </a:xfrm>
           <a:prstGeom prst="rect">
             <a:avLst/>
@@ -4256,8 +4256,8 @@
         </p:nvSpPr>
         <p:spPr>
           <a:xfrm>
-            <a:off x="868680" y="4599432"/>
-            <a:ext cx="4114800" cy="278892"/>
+            <a:off x="868680" y="4266590"/>
+            <a:ext cx="4114800" cy="246888"/>
           </a:xfrm>
           <a:prstGeom prst="rect">
             <a:avLst/>
@@ -4295,8 +4295,8 @@
         </p:nvSpPr>
         <p:spPr>
           <a:xfrm>
-            <a:off x="4892040" y="4599432"/>
-            <a:ext cx="1463040" cy="278892"/>
+            <a:off x="4892040" y="4266590"/>
+            <a:ext cx="1463040" cy="246888"/>
           </a:xfrm>
           <a:prstGeom prst="rect">
             <a:avLst/>
@@ -4334,8 +4334,8 @@
         </p:nvSpPr>
         <p:spPr>
           <a:xfrm>
-            <a:off x="868680" y="4919472"/>
-            <a:ext cx="4114800" cy="278892"/>
+            <a:off x="868680" y="4547311"/>
+            <a:ext cx="4114800" cy="246888"/>
           </a:xfrm>
           <a:prstGeom prst="rect">
             <a:avLst/>
@@ -4373,8 +4373,8 @@
         </p:nvSpPr>
         <p:spPr>
           <a:xfrm>
-            <a:off x="4892040" y="4919472"/>
-            <a:ext cx="1463040" cy="278892"/>
+            <a:off x="4892040" y="4547311"/>
+            <a:ext cx="1463040" cy="246888"/>
           </a:xfrm>
           <a:prstGeom prst="rect">
             <a:avLst/>
@@ -4412,8 +4412,8 @@
         </p:nvSpPr>
         <p:spPr>
           <a:xfrm>
-            <a:off x="868680" y="5239512"/>
-            <a:ext cx="4114800" cy="278892"/>
+            <a:off x="868680" y="4828032"/>
+            <a:ext cx="4114800" cy="246888"/>
           </a:xfrm>
           <a:prstGeom prst="rect">
             <a:avLst/>
@@ -4451,8 +4451,8 @@
         </p:nvSpPr>
         <p:spPr>
           <a:xfrm>
-            <a:off x="4892040" y="5239512"/>
-            <a:ext cx="1463040" cy="278892"/>
+            <a:off x="4892040" y="4828032"/>
+            <a:ext cx="1463040" cy="246888"/>
           </a:xfrm>
           <a:prstGeom prst="rect">
             <a:avLst/>
@@ -4490,8 +4490,8 @@
         </p:nvSpPr>
         <p:spPr>
           <a:xfrm>
-            <a:off x="548640" y="5541264"/>
-            <a:ext cx="6492240" cy="315468"/>
+            <a:off x="548640" y="5090465"/>
+            <a:ext cx="6492240" cy="283464"/>
           </a:xfrm>
           <a:prstGeom prst="rect">
             <a:avLst/>
@@ -4510,8 +4510,8 @@
         </p:nvSpPr>
         <p:spPr>
           <a:xfrm>
-            <a:off x="868680" y="5559552"/>
-            <a:ext cx="4114800" cy="278892"/>
+            <a:off x="868680" y="5108753"/>
+            <a:ext cx="4114800" cy="246888"/>
           </a:xfrm>
           <a:prstGeom prst="rect">
             <a:avLst/>
@@ -4549,8 +4549,8 @@
         </p:nvSpPr>
         <p:spPr>
           <a:xfrm>
-            <a:off x="4892040" y="5559552"/>
-            <a:ext cx="1463040" cy="278892"/>
+            <a:off x="4892040" y="5108753"/>
+            <a:ext cx="1463040" cy="246888"/>
           </a:xfrm>
           <a:prstGeom prst="rect">
             <a:avLst/>
@@ -4588,8 +4588,8 @@
         </p:nvSpPr>
         <p:spPr>
           <a:xfrm>
-            <a:off x="6400800" y="5559552"/>
-            <a:ext cx="457200" cy="278892"/>
+            <a:off x="6400800" y="5108753"/>
+            <a:ext cx="457200" cy="246888"/>
           </a:xfrm>
           <a:prstGeom prst="rect">
             <a:avLst/>
@@ -4627,7 +4627,7 @@
         </p:nvSpPr>
         <p:spPr>
           <a:xfrm>
-            <a:off x="548640" y="5925312"/>
+            <a:off x="548640" y="5435194"/>
             <a:ext cx="6492240" cy="18288"/>
           </a:xfrm>
           <a:prstGeom prst="rect">
@@ -4647,7 +4647,7 @@
         </p:nvSpPr>
         <p:spPr>
           <a:xfrm>
-            <a:off x="868680" y="6025896"/>
+            <a:off x="868680" y="5535778"/>
             <a:ext cx="4297680" cy="384048"/>
           </a:xfrm>
           <a:prstGeom prst="rect">
@@ -4700,7 +4700,7 @@
         </p:nvSpPr>
         <p:spPr>
           <a:xfrm>
-            <a:off x="4892040" y="6025896"/>
+            <a:off x="4892040" y="5535778"/>
             <a:ext cx="1463040" cy="384048"/>
           </a:xfrm>
           <a:prstGeom prst="rect">
@@ -4739,7 +4739,7 @@
         </p:nvSpPr>
         <p:spPr>
           <a:xfrm>
-            <a:off x="6400800" y="6025896"/>
+            <a:off x="6400800" y="5535778"/>
             <a:ext cx="457200" cy="384048"/>
           </a:xfrm>
           <a:prstGeom prst="rect">

</xml_diff>